<commit_message>
Update sample screenshots, drop README.html
</commit_message>
<xml_diff>
--- a/04_Architecture_diagram.pptx
+++ b/04_Architecture_diagram.pptx
@@ -106,6 +106,11 @@
       </a:defRPr>
     </a:lvl9pPr>
   </p:defaultTextStyle>
+  <p:extLst>
+    <p:ext uri="{EFAFB233-063F-42B5-8137-9DF3F51BA10A}">
+      <p15:sldGuideLst xmlns:p15="http://schemas.microsoft.com/office/powerpoint/2012/main"/>
+    </p:ext>
+  </p:extLst>
 </p:presentation>
 </file>
 
@@ -258,7 +263,7 @@
           <a:p>
             <a:fld id="{AA049EFF-827C-425A-A319-FCB1BA1081CD}" type="datetimeFigureOut">
               <a:rPr lang="en-SG" smtClean="0"/>
-              <a:t>3 Sept 2026</a:t>
+              <a:t>13 Sept 2026</a:t>
             </a:fld>
             <a:endParaRPr lang="en-SG"/>
           </a:p>
@@ -458,7 +463,7 @@
           <a:p>
             <a:fld id="{AA049EFF-827C-425A-A319-FCB1BA1081CD}" type="datetimeFigureOut">
               <a:rPr lang="en-SG" smtClean="0"/>
-              <a:t>3 Sept 2026</a:t>
+              <a:t>13 Sept 2026</a:t>
             </a:fld>
             <a:endParaRPr lang="en-SG"/>
           </a:p>
@@ -668,7 +673,7 @@
           <a:p>
             <a:fld id="{AA049EFF-827C-425A-A319-FCB1BA1081CD}" type="datetimeFigureOut">
               <a:rPr lang="en-SG" smtClean="0"/>
-              <a:t>3 Sept 2026</a:t>
+              <a:t>13 Sept 2026</a:t>
             </a:fld>
             <a:endParaRPr lang="en-SG"/>
           </a:p>
@@ -868,7 +873,7 @@
           <a:p>
             <a:fld id="{AA049EFF-827C-425A-A319-FCB1BA1081CD}" type="datetimeFigureOut">
               <a:rPr lang="en-SG" smtClean="0"/>
-              <a:t>3 Sept 2026</a:t>
+              <a:t>13 Sept 2026</a:t>
             </a:fld>
             <a:endParaRPr lang="en-SG"/>
           </a:p>
@@ -1144,7 +1149,7 @@
           <a:p>
             <a:fld id="{AA049EFF-827C-425A-A319-FCB1BA1081CD}" type="datetimeFigureOut">
               <a:rPr lang="en-SG" smtClean="0"/>
-              <a:t>3 Sept 2026</a:t>
+              <a:t>13 Sept 2026</a:t>
             </a:fld>
             <a:endParaRPr lang="en-SG"/>
           </a:p>
@@ -1412,7 +1417,7 @@
           <a:p>
             <a:fld id="{AA049EFF-827C-425A-A319-FCB1BA1081CD}" type="datetimeFigureOut">
               <a:rPr lang="en-SG" smtClean="0"/>
-              <a:t>3 Sept 2026</a:t>
+              <a:t>13 Sept 2026</a:t>
             </a:fld>
             <a:endParaRPr lang="en-SG"/>
           </a:p>
@@ -1827,7 +1832,7 @@
           <a:p>
             <a:fld id="{AA049EFF-827C-425A-A319-FCB1BA1081CD}" type="datetimeFigureOut">
               <a:rPr lang="en-SG" smtClean="0"/>
-              <a:t>3 Sept 2026</a:t>
+              <a:t>13 Sept 2026</a:t>
             </a:fld>
             <a:endParaRPr lang="en-SG"/>
           </a:p>
@@ -1969,7 +1974,7 @@
           <a:p>
             <a:fld id="{AA049EFF-827C-425A-A319-FCB1BA1081CD}" type="datetimeFigureOut">
               <a:rPr lang="en-SG" smtClean="0"/>
-              <a:t>3 Sept 2026</a:t>
+              <a:t>13 Sept 2026</a:t>
             </a:fld>
             <a:endParaRPr lang="en-SG"/>
           </a:p>
@@ -2082,7 +2087,7 @@
           <a:p>
             <a:fld id="{AA049EFF-827C-425A-A319-FCB1BA1081CD}" type="datetimeFigureOut">
               <a:rPr lang="en-SG" smtClean="0"/>
-              <a:t>3 Sept 2026</a:t>
+              <a:t>13 Sept 2026</a:t>
             </a:fld>
             <a:endParaRPr lang="en-SG"/>
           </a:p>
@@ -2395,7 +2400,7 @@
           <a:p>
             <a:fld id="{AA049EFF-827C-425A-A319-FCB1BA1081CD}" type="datetimeFigureOut">
               <a:rPr lang="en-SG" smtClean="0"/>
-              <a:t>3 Sept 2026</a:t>
+              <a:t>13 Sept 2026</a:t>
             </a:fld>
             <a:endParaRPr lang="en-SG"/>
           </a:p>
@@ -2684,7 +2689,7 @@
           <a:p>
             <a:fld id="{AA049EFF-827C-425A-A319-FCB1BA1081CD}" type="datetimeFigureOut">
               <a:rPr lang="en-SG" smtClean="0"/>
-              <a:t>3 Sept 2026</a:t>
+              <a:t>13 Sept 2026</a:t>
             </a:fld>
             <a:endParaRPr lang="en-SG"/>
           </a:p>
@@ -2927,7 +2932,7 @@
           <a:p>
             <a:fld id="{AA049EFF-827C-425A-A319-FCB1BA1081CD}" type="datetimeFigureOut">
               <a:rPr lang="en-SG" smtClean="0"/>
-              <a:t>3 Sept 2026</a:t>
+              <a:t>13 Sept 2026</a:t>
             </a:fld>
             <a:endParaRPr lang="en-SG"/>
           </a:p>
@@ -3478,10 +3483,10 @@
       </p:grpSpPr>
       <p:pic>
         <p:nvPicPr>
-          <p:cNvPr id="3" name="Picture 2">
-            <a:extLst>
-              <a:ext uri="{FF2B5EF4-FFF2-40B4-BE49-F238E27FC236}">
-                <a16:creationId xmlns:a16="http://schemas.microsoft.com/office/drawing/2014/main" id="{B559D626-6EDE-C28C-52C3-AD7F987A86F6}"/>
+          <p:cNvPr id="6" name="Picture 5">
+            <a:extLst>
+              <a:ext uri="{FF2B5EF4-FFF2-40B4-BE49-F238E27FC236}">
+                <a16:creationId xmlns:a16="http://schemas.microsoft.com/office/drawing/2014/main" id="{488B6BCD-76FD-7F5A-B2C3-0DC5C43C3089}"/>
               </a:ext>
             </a:extLst>
           </p:cNvPr>
@@ -3498,8 +3503,8 @@
         </p:blipFill>
         <p:spPr>
           <a:xfrm>
-            <a:off x="262647" y="97475"/>
-            <a:ext cx="5033559" cy="6663049"/>
+            <a:off x="6419553" y="51206"/>
+            <a:ext cx="5772447" cy="4483330"/>
           </a:xfrm>
           <a:prstGeom prst="rect">
             <a:avLst/>
@@ -3508,10 +3513,10 @@
       </p:pic>
       <p:pic>
         <p:nvPicPr>
-          <p:cNvPr id="6" name="Picture 5">
-            <a:extLst>
-              <a:ext uri="{FF2B5EF4-FFF2-40B4-BE49-F238E27FC236}">
-                <a16:creationId xmlns:a16="http://schemas.microsoft.com/office/drawing/2014/main" id="{488B6BCD-76FD-7F5A-B2C3-0DC5C43C3089}"/>
+          <p:cNvPr id="5" name="Picture 4">
+            <a:extLst>
+              <a:ext uri="{FF2B5EF4-FFF2-40B4-BE49-F238E27FC236}">
+                <a16:creationId xmlns:a16="http://schemas.microsoft.com/office/drawing/2014/main" id="{CA8CA2D5-66E1-622D-1F2C-F0DE206BC19B}"/>
               </a:ext>
             </a:extLst>
           </p:cNvPr>
@@ -3528,8 +3533,8 @@
         </p:blipFill>
         <p:spPr>
           <a:xfrm>
-            <a:off x="5377535" y="97475"/>
-            <a:ext cx="5772447" cy="4483330"/>
+            <a:off x="132658" y="-1"/>
+            <a:ext cx="6379997" cy="6832397"/>
           </a:xfrm>
           <a:prstGeom prst="rect">
             <a:avLst/>

</xml_diff>